<commit_message>
Update title slide with team members Harshith K, Manideep P, Rishvik K
</commit_message>
<xml_diff>
--- a/FinTrack_Presentation.pptx
+++ b/FinTrack_Presentation.pptx
@@ -3162,10 +3162,54 @@
               <a:cs typeface="Times New Roman" panose="02020603050405020304" pitchFamily="18" charset="0"/>
             </a:endParaRPr>
           </a:p>
-          <a:p/>
-          <a:p/>
-          <a:p/>
-          <a:p/>
+          <a:p>
+            <a:pPr>
+              <a:defRPr sz="1400" b="1">
+                <a:solidFill>
+                  <a:srgbClr val="1E293B"/>
+                </a:solidFill>
+              </a:defRPr>
+            </a:pPr>
+            <a:r>
+              <a:t>Team Members:</a:t>
+            </a:r>
+          </a:p>
+          <a:p>
+            <a:pPr>
+              <a:defRPr sz="1300">
+                <a:solidFill>
+                  <a:srgbClr val="334155"/>
+                </a:solidFill>
+              </a:defRPr>
+            </a:pPr>
+            <a:r>
+              <a:t>  1. Harshith K</a:t>
+            </a:r>
+          </a:p>
+          <a:p>
+            <a:pPr>
+              <a:defRPr sz="1300">
+                <a:solidFill>
+                  <a:srgbClr val="334155"/>
+                </a:solidFill>
+              </a:defRPr>
+            </a:pPr>
+            <a:r>
+              <a:t>  2. Manideep P</a:t>
+            </a:r>
+          </a:p>
+          <a:p>
+            <a:pPr>
+              <a:defRPr sz="1300">
+                <a:solidFill>
+                  <a:srgbClr val="334155"/>
+                </a:solidFill>
+              </a:defRPr>
+            </a:pPr>
+            <a:r>
+              <a:t>  3. Rishvik K</a:t>
+            </a:r>
+          </a:p>
           <a:p/>
           <a:p/>
           <a:p/>

</xml_diff>

<commit_message>
Add smart salary reduction downscaling, lean budget presets, and deficit protection
</commit_message>
<xml_diff>
--- a/FinTrack_Presentation.pptx
+++ b/FinTrack_Presentation.pptx
@@ -338,6 +338,15 @@
     </p:ext>
   </p:extLst>
 </p:presentation>
+</file>
+
+<file path=ppt/revisionInfo.xml><?xml version="1.0" encoding="utf-8"?>
+<p1510:revInfo xmlns:a="http://schemas.openxmlformats.org/drawingml/2006/main" xmlns:r="http://schemas.openxmlformats.org/officeDocument/2006/relationships" xmlns:p1510="http://schemas.microsoft.com/office/powerpoint/2015/10/main">
+  <p1510:revLst>
+    <p1510:client id="{3AD1B38F-28C7-E72D-4C46-98BF8FD7593F}" v="1" dt="2026-10-04T10:20:56.816"/>
+    <p1510:client id="{74501F18-4EDE-86D2-DD94-ACD56402A448}" v="193" dt="2026-10-04T10:28:01.021"/>
+  </p1510:revLst>
+</p1510:revInfo>
 </file>
 
 <file path=ppt/notesMasters/notesMaster1.xml><?xml version="1.0" encoding="utf-8"?>
@@ -555,180 +564,6 @@
             <p:ph type="sldImg"/>
           </p:nvPr>
         </p:nvSpPr>
-        <p:spPr/>
-      </p:sp>
-      <p:sp>
-        <p:nvSpPr>
-          <p:cNvPr id="3" name="Notes Placeholder 2"/>
-          <p:cNvSpPr>
-            <a:spLocks noGrp="1"/>
-          </p:cNvSpPr>
-          <p:nvPr>
-            <p:ph type="body" sz="quarter" idx="1"/>
-          </p:nvPr>
-        </p:nvSpPr>
-        <p:spPr/>
-        <p:txBody>
-          <a:bodyPr/>
-          <a:lstStyle/>
-          <a:p>
-            <a:r>
-              <a:t>Introduce the team, the guide and the project title. MedShare is a DBMS project for sharing medical equipment between hospitals.</a:t>
-            </a:r>
-          </a:p>
-        </p:txBody>
-      </p:sp>
-    </p:spTree>
-  </p:cSld>
-  <p:clrMapOvr>
-    <a:masterClrMapping/>
-  </p:clrMapOvr>
-</p:notes>
-</file>
-
-<file path=ppt/notesSlides/notesSlide10.xml><?xml version="1.0" encoding="utf-8"?>
-<p:notes xmlns:a="http://schemas.openxmlformats.org/drawingml/2006/main" xmlns:r="http://schemas.openxmlformats.org/officeDocument/2006/relationships" xmlns:p="http://schemas.openxmlformats.org/presentationml/2006/main">
-  <p:cSld>
-    <p:spTree>
-      <p:nvGrpSpPr>
-        <p:cNvPr id="1" name=""/>
-        <p:cNvGrpSpPr/>
-        <p:nvPr/>
-      </p:nvGrpSpPr>
-      <p:grpSpPr>
-        <a:xfrm>
-          <a:off x="0" y="0"/>
-          <a:ext cx="0" cy="0"/>
-          <a:chOff x="0" y="0"/>
-          <a:chExt cx="0" cy="0"/>
-        </a:xfrm>
-      </p:grpSpPr>
-      <p:sp>
-        <p:nvSpPr>
-          <p:cNvPr id="2" name="Slide Image Placeholder 1"/>
-          <p:cNvSpPr>
-            <a:spLocks noGrp="1" noRot="1" noChangeAspect="1"/>
-          </p:cNvSpPr>
-          <p:nvPr>
-            <p:ph type="sldImg"/>
-          </p:nvPr>
-        </p:nvSpPr>
-        <p:spPr/>
-      </p:sp>
-      <p:sp>
-        <p:nvSpPr>
-          <p:cNvPr id="3" name="Notes Placeholder 2"/>
-          <p:cNvSpPr>
-            <a:spLocks noGrp="1"/>
-          </p:cNvSpPr>
-          <p:nvPr>
-            <p:ph type="body" sz="quarter" idx="1"/>
-          </p:nvPr>
-        </p:nvSpPr>
-        <p:spPr/>
-        <p:txBody>
-          <a:bodyPr/>
-          <a:lstStyle/>
-          <a:p>
-            <a:r>
-              <a:t>sp_accept_offer runs inside one transaction: it locks the offer and request rows with SELECT FOR UPDATE, checks that units are still available, reserves them, updates the request and notifies the lender, then commits. If anything fails, the handler does ROLLBACK. Because of row locking, two users accepting at the same time cannot reserve the same units. Security: the app uses its own MySQL user with limited privileges, bcrypt passwords, JWT login and role checks.</a:t>
-            </a:r>
-          </a:p>
-        </p:txBody>
-      </p:sp>
-    </p:spTree>
-  </p:cSld>
-  <p:clrMapOvr>
-    <a:masterClrMapping/>
-  </p:clrMapOvr>
-</p:notes>
-</file>
-
-<file path=ppt/notesSlides/notesSlide11.xml><?xml version="1.0" encoding="utf-8"?>
-<p:notes xmlns:a="http://schemas.openxmlformats.org/drawingml/2006/main" xmlns:r="http://schemas.openxmlformats.org/officeDocument/2006/relationships" xmlns:p="http://schemas.openxmlformats.org/presentationml/2006/main">
-  <p:cSld>
-    <p:spTree>
-      <p:nvGrpSpPr>
-        <p:cNvPr id="1" name=""/>
-        <p:cNvGrpSpPr/>
-        <p:nvPr/>
-      </p:nvGrpSpPr>
-      <p:grpSpPr>
-        <a:xfrm>
-          <a:off x="0" y="0"/>
-          <a:ext cx="0" cy="0"/>
-          <a:chOff x="0" y="0"/>
-          <a:chExt cx="0" cy="0"/>
-        </a:xfrm>
-      </p:grpSpPr>
-      <p:sp>
-        <p:nvSpPr>
-          <p:cNvPr id="2" name="Slide Image Placeholder 1"/>
-          <p:cNvSpPr>
-            <a:spLocks noGrp="1" noRot="1" noChangeAspect="1"/>
-          </p:cNvSpPr>
-          <p:nvPr>
-            <p:ph type="sldImg"/>
-          </p:nvPr>
-        </p:nvSpPr>
-        <p:spPr/>
-      </p:sp>
-      <p:sp>
-        <p:nvSpPr>
-          <p:cNvPr id="3" name="Notes Placeholder 2"/>
-          <p:cNvSpPr>
-            <a:spLocks noGrp="1"/>
-          </p:cNvSpPr>
-          <p:nvPr>
-            <p:ph type="body" sz="quarter" idx="1"/>
-          </p:nvPr>
-        </p:nvSpPr>
-        <p:spPr/>
-        <p:txBody>
-          <a:bodyPr/>
-          <a:lstStyle/>
-          <a:p>
-            <a:r>
-              <a:t>Walk through the flow from left to right. If no hospital helps, the request is escalated to the health authority. Read the project numbers and seed data. Finish with the conclusion and future scope, then show the demo.</a:t>
-            </a:r>
-          </a:p>
-        </p:txBody>
-      </p:sp>
-    </p:spTree>
-  </p:cSld>
-  <p:clrMapOvr>
-    <a:masterClrMapping/>
-  </p:clrMapOvr>
-</p:notes>
-</file>
-
-<file path=ppt/notesSlides/notesSlide2.xml><?xml version="1.0" encoding="utf-8"?>
-<p:notes xmlns:a="http://schemas.openxmlformats.org/drawingml/2006/main" xmlns:r="http://schemas.openxmlformats.org/officeDocument/2006/relationships" xmlns:p="http://schemas.openxmlformats.org/presentationml/2006/main">
-  <p:cSld>
-    <p:spTree>
-      <p:nvGrpSpPr>
-        <p:cNvPr id="1" name=""/>
-        <p:cNvGrpSpPr/>
-        <p:nvPr/>
-      </p:nvGrpSpPr>
-      <p:grpSpPr>
-        <a:xfrm>
-          <a:off x="0" y="0"/>
-          <a:ext cx="0" cy="0"/>
-          <a:chOff x="0" y="0"/>
-          <a:chExt cx="0" cy="0"/>
-        </a:xfrm>
-      </p:grpSpPr>
-      <p:sp>
-        <p:nvSpPr>
-          <p:cNvPr id="2" name="Slide Image Placeholder 1"/>
-          <p:cNvSpPr>
-            <a:spLocks noGrp="1" noRot="1" noChangeAspect="1"/>
-          </p:cNvSpPr>
-          <p:nvPr>
-            <p:ph type="sldImg"/>
-          </p:nvPr>
-        </p:nvSpPr>
         <p:spPr>
           <a:xfrm>
             <a:off x="381000" y="685800"/>
@@ -853,7 +688,65 @@
 </p:notes>
 </file>
 
-<file path=ppt/notesSlides/notesSlide3.xml><?xml version="1.0" encoding="utf-8"?>
+<file path=ppt/notesSlides/notesSlide10.xml><?xml version="1.0" encoding="utf-8"?>
+<p:notes xmlns:a="http://schemas.openxmlformats.org/drawingml/2006/main" xmlns:r="http://schemas.openxmlformats.org/officeDocument/2006/relationships" xmlns:p="http://schemas.openxmlformats.org/presentationml/2006/main">
+  <p:cSld>
+    <p:spTree>
+      <p:nvGrpSpPr>
+        <p:cNvPr id="1" name=""/>
+        <p:cNvGrpSpPr/>
+        <p:nvPr/>
+      </p:nvGrpSpPr>
+      <p:grpSpPr>
+        <a:xfrm>
+          <a:off x="0" y="0"/>
+          <a:ext cx="0" cy="0"/>
+          <a:chOff x="0" y="0"/>
+          <a:chExt cx="0" cy="0"/>
+        </a:xfrm>
+      </p:grpSpPr>
+      <p:sp>
+        <p:nvSpPr>
+          <p:cNvPr id="2" name="Slide Image Placeholder 1"/>
+          <p:cNvSpPr>
+            <a:spLocks noGrp="1" noRot="1" noChangeAspect="1"/>
+          </p:cNvSpPr>
+          <p:nvPr>
+            <p:ph type="sldImg"/>
+          </p:nvPr>
+        </p:nvSpPr>
+        <p:spPr/>
+      </p:sp>
+      <p:sp>
+        <p:nvSpPr>
+          <p:cNvPr id="3" name="Notes Placeholder 2"/>
+          <p:cNvSpPr>
+            <a:spLocks noGrp="1"/>
+          </p:cNvSpPr>
+          <p:nvPr>
+            <p:ph type="body" sz="quarter" idx="1"/>
+          </p:nvPr>
+        </p:nvSpPr>
+        <p:spPr/>
+        <p:txBody>
+          <a:bodyPr/>
+          <a:lstStyle/>
+          <a:p>
+            <a:r>
+              <a:t>Walk through the flow from left to right. If no hospital helps, the request is escalated to the health authority. Read the project numbers and seed data. Finish with the conclusion and future scope, then show the demo.</a:t>
+            </a:r>
+          </a:p>
+        </p:txBody>
+      </p:sp>
+    </p:spTree>
+  </p:cSld>
+  <p:clrMapOvr>
+    <a:masterClrMapping/>
+  </p:clrMapOvr>
+</p:notes>
+</file>
+
+<file path=ppt/notesSlides/notesSlide2.xml><?xml version="1.0" encoding="utf-8"?>
 <p:notes xmlns:a="http://schemas.openxmlformats.org/drawingml/2006/main" xmlns:r="http://schemas.openxmlformats.org/officeDocument/2006/relationships" xmlns:p="http://schemas.openxmlformats.org/presentationml/2006/main">
   <p:cSld>
     <p:spTree>
@@ -1004,7 +897,7 @@
 </p:notes>
 </file>
 
-<file path=ppt/notesSlides/notesSlide4.xml><?xml version="1.0" encoding="utf-8"?>
+<file path=ppt/notesSlides/notesSlide3.xml><?xml version="1.0" encoding="utf-8"?>
 <p:notes xmlns:a="http://schemas.openxmlformats.org/drawingml/2006/main" xmlns:r="http://schemas.openxmlformats.org/officeDocument/2006/relationships" xmlns:p="http://schemas.openxmlformats.org/presentationml/2006/main">
   <p:cSld>
     <p:spTree>
@@ -1155,7 +1048,7 @@
 </p:notes>
 </file>
 
-<file path=ppt/notesSlides/notesSlide5.xml><?xml version="1.0" encoding="utf-8"?>
+<file path=ppt/notesSlides/notesSlide4.xml><?xml version="1.0" encoding="utf-8"?>
 <p:notes xmlns:a="http://schemas.openxmlformats.org/drawingml/2006/main" xmlns:r="http://schemas.openxmlformats.org/officeDocument/2006/relationships" xmlns:p="http://schemas.openxmlformats.org/presentationml/2006/main">
   <p:cSld>
     <p:spTree>
@@ -1306,7 +1199,7 @@
 </p:notes>
 </file>
 
-<file path=ppt/notesSlides/notesSlide6.xml><?xml version="1.0" encoding="utf-8"?>
+<file path=ppt/notesSlides/notesSlide5.xml><?xml version="1.0" encoding="utf-8"?>
 <p:notes xmlns:a="http://schemas.openxmlformats.org/drawingml/2006/main" xmlns:r="http://schemas.openxmlformats.org/officeDocument/2006/relationships" xmlns:p="http://schemas.openxmlformats.org/presentationml/2006/main">
   <p:cSld>
     <p:spTree>
@@ -1457,7 +1350,7 @@
 </p:notes>
 </file>
 
-<file path=ppt/notesSlides/notesSlide7.xml><?xml version="1.0" encoding="utf-8"?>
+<file path=ppt/notesSlides/notesSlide6.xml><?xml version="1.0" encoding="utf-8"?>
 <p:notes xmlns:a="http://schemas.openxmlformats.org/drawingml/2006/main" xmlns:r="http://schemas.openxmlformats.org/officeDocument/2006/relationships" xmlns:p="http://schemas.openxmlformats.org/presentationml/2006/main">
   <p:cSld>
     <p:spTree>
@@ -1608,7 +1501,7 @@
 </p:notes>
 </file>
 
-<file path=ppt/notesSlides/notesSlide8.xml><?xml version="1.0" encoding="utf-8"?>
+<file path=ppt/notesSlides/notesSlide7.xml><?xml version="1.0" encoding="utf-8"?>
 <p:notes xmlns:a="http://schemas.openxmlformats.org/drawingml/2006/main" xmlns:r="http://schemas.openxmlformats.org/officeDocument/2006/relationships" xmlns:p="http://schemas.openxmlformats.org/presentationml/2006/main">
   <p:cSld>
     <p:spTree>
@@ -1759,6 +1652,64 @@
 </p:notes>
 </file>
 
+<file path=ppt/notesSlides/notesSlide8.xml><?xml version="1.0" encoding="utf-8"?>
+<p:notes xmlns:a="http://schemas.openxmlformats.org/drawingml/2006/main" xmlns:r="http://schemas.openxmlformats.org/officeDocument/2006/relationships" xmlns:p="http://schemas.openxmlformats.org/presentationml/2006/main">
+  <p:cSld>
+    <p:spTree>
+      <p:nvGrpSpPr>
+        <p:cNvPr id="1" name=""/>
+        <p:cNvGrpSpPr/>
+        <p:nvPr/>
+      </p:nvGrpSpPr>
+      <p:grpSpPr>
+        <a:xfrm>
+          <a:off x="0" y="0"/>
+          <a:ext cx="0" cy="0"/>
+          <a:chOff x="0" y="0"/>
+          <a:chExt cx="0" cy="0"/>
+        </a:xfrm>
+      </p:grpSpPr>
+      <p:sp>
+        <p:nvSpPr>
+          <p:cNvPr id="2" name="Slide Image Placeholder 1"/>
+          <p:cNvSpPr>
+            <a:spLocks noGrp="1" noRot="1" noChangeAspect="1"/>
+          </p:cNvSpPr>
+          <p:nvPr>
+            <p:ph type="sldImg"/>
+          </p:nvPr>
+        </p:nvSpPr>
+        <p:spPr/>
+      </p:sp>
+      <p:sp>
+        <p:nvSpPr>
+          <p:cNvPr id="3" name="Notes Placeholder 2"/>
+          <p:cNvSpPr>
+            <a:spLocks noGrp="1"/>
+          </p:cNvSpPr>
+          <p:nvPr>
+            <p:ph type="body" sz="quarter" idx="1"/>
+          </p:nvPr>
+        </p:nvSpPr>
+        <p:spPr/>
+        <p:txBody>
+          <a:bodyPr/>
+          <a:lstStyle/>
+          <a:p>
+            <a:r>
+              <a:t>Procedures: the main steps like create request, make offer, accept offer, dispatch, receive and return. Functions: fn_distance_km uses the Haversine formula, fn_available_count counts available units, fn_calculate_emi calculates the loan EMI. Triggers: for example a hospital cannot offer to its own request, and every change is written to audit_log. Views: ready-made queries for dashboards.</a:t>
+            </a:r>
+          </a:p>
+        </p:txBody>
+      </p:sp>
+    </p:spTree>
+  </p:cSld>
+  <p:clrMapOvr>
+    <a:masterClrMapping/>
+  </p:clrMapOvr>
+</p:notes>
+</file>
+
 <file path=ppt/notesSlides/notesSlide9.xml><?xml version="1.0" encoding="utf-8"?>
 <p:notes xmlns:a="http://schemas.openxmlformats.org/drawingml/2006/main" xmlns:r="http://schemas.openxmlformats.org/officeDocument/2006/relationships" xmlns:p="http://schemas.openxmlformats.org/presentationml/2006/main">
   <p:cSld>
@@ -1804,7 +1755,7 @@
           <a:lstStyle/>
           <a:p>
             <a:r>
-              <a:t>Procedures: the main steps like create request, make offer, accept offer, dispatch, receive and return. Functions: fn_distance_km uses the Haversine formula, fn_available_count counts available units, fn_calculate_emi calculates the loan EMI. Triggers: for example a hospital cannot offer to its own request, and every change is written to audit_log. Views: ready-made queries for dashboards.</a:t>
+              <a:t>sp_accept_offer runs inside one transaction: it locks the offer and request rows with SELECT FOR UPDATE, checks that units are still available, reserves them, updates the request and notifies the lender, then commits. If anything fails, the handler does ROLLBACK. Because of row locking, two users accepting at the same time cannot reserve the same units. Security: the app uses its own MySQL user with limited privileges, bcrypt passwords, JWT login and role checks.</a:t>
             </a:r>
           </a:p>
         </p:txBody>
@@ -3096,7 +3047,7 @@
           <p:nvPr/>
         </p:nvPicPr>
         <p:blipFill>
-          <a:blip r:embed="rId3"/>
+          <a:blip r:embed="rId2"/>
           <a:stretch>
             <a:fillRect/>
           </a:stretch>
@@ -3174,14 +3125,29 @@
           </a:bodyPr>
           <a:lstStyle/>
           <a:p>
-            <a:pPr>
-              <a:defRPr sz="2800" b="1">
-                <a:latin typeface="Calibri"/>
-              </a:defRPr>
+            <a:pPr algn="ctr">
+              <a:spcAft>
+                <a:spcPts val="600"/>
+              </a:spcAft>
             </a:pPr>
             <a:r>
-              <a:t>FINTRACK</a:t>
-            </a:r>
+              <a:rPr lang="en-US" sz="2800" kern="2400" dirty="0">
+                <a:solidFill>
+                  <a:schemeClr val="bg1"/>
+                </a:solidFill>
+                <a:latin typeface="Times New Roman" panose="02020603050405020304" pitchFamily="18" charset="0"/>
+                <a:ea typeface="MS Mincho" panose="02020609040205080304" pitchFamily="49" charset="-128"/>
+              </a:rPr>
+              <a:t>TITLE OF THE PROJECT</a:t>
+            </a:r>
+            <a:endParaRPr lang="en-US" sz="2800" dirty="0">
+              <a:solidFill>
+                <a:schemeClr val="bg1"/>
+              </a:solidFill>
+              <a:effectLst/>
+              <a:latin typeface="Times New Roman" panose="02020603050405020304" pitchFamily="18" charset="0"/>
+              <a:ea typeface="MS Mincho" panose="02020609040205080304" pitchFamily="49" charset="-128"/>
+            </a:endParaRPr>
           </a:p>
         </p:txBody>
       </p:sp>
@@ -3223,79 +3189,238 @@
           </a:bodyPr>
           <a:lstStyle/>
           <a:p>
-            <a:r>
-              <a:t>Team_No:  13                    		   		 Project  Advisor:  Divya K V</a:t>
-            </a:r>
-          </a:p>
-        </p:txBody>
-      </p:sp>
-      <p:sp>
-        <p:nvSpPr>
-          <p:cNvPr id="17" name="TextBox 16"/>
-          <p:cNvSpPr txBox="1"/>
-          <p:nvPr/>
-        </p:nvSpPr>
-        <p:spPr>
-          <a:xfrm>
-            <a:off x="822960" y="841248"/>
-            <a:ext cx="10561320" cy="457200"/>
-          </a:xfrm>
-          <a:prstGeom prst="rect">
-            <a:avLst/>
-          </a:prstGeom>
-          <a:noFill/>
-        </p:spPr>
-        <p:txBody>
-          <a:bodyPr wrap="square" lIns="36576" tIns="36576" rIns="36576" bIns="36576" anchor="t">
-            <a:spAutoFit/>
-          </a:bodyPr>
-          <a:lstStyle/>
-          <a:p>
             <a:pPr>
-              <a:defRPr sz="1600" b="1">
-                <a:latin typeface="Calibri"/>
+              <a:lnSpc>
+                <a:spcPct val="80000"/>
+              </a:lnSpc>
+              <a:spcBef>
+                <a:spcPts val="400"/>
+              </a:spcBef>
+              <a:defRPr sz="2000" b="1">
+                <a:latin typeface="+mn-lt"/>
+                <a:ea typeface="+mn-ea"/>
+                <a:cs typeface="+mn-cs"/>
+                <a:sym typeface="Arial"/>
               </a:defRPr>
             </a:pPr>
             <a:r>
-              <a:t>Personal Finance Management &amp; Spend Prediction System</a:t>
-            </a:r>
-          </a:p>
-        </p:txBody>
-      </p:sp>
-      <p:sp>
-        <p:nvSpPr>
-          <p:cNvPr id="18" name="TextBox 17"/>
-          <p:cNvSpPr txBox="1"/>
-          <p:nvPr/>
-        </p:nvSpPr>
-        <p:spPr>
-          <a:xfrm>
-            <a:off x="822960" y="1325880"/>
-            <a:ext cx="10561320" cy="320088"/>
-          </a:xfrm>
-          <a:prstGeom prst="rect">
-            <a:avLst/>
-          </a:prstGeom>
-          <a:noFill/>
-        </p:spPr>
-        <p:txBody>
-          <a:bodyPr wrap="square" lIns="36576" tIns="36576" rIns="36576" bIns="36576" anchor="t">
-            <a:spAutoFit/>
-          </a:bodyPr>
-          <a:lstStyle/>
-          <a:p>
-            <a:r>
-              <a:t>22AIE303 – Database Management Systems</a:t>
-            </a:r>
+              <a:rPr sz="2000" dirty="0">
+                <a:solidFill>
+                  <a:schemeClr val="bg1">
+                    <a:lumMod val="95000"/>
+                  </a:schemeClr>
+                </a:solidFill>
+              </a:rPr>
+              <a:t>Team</a:t>
+            </a:r>
+            <a:r>
+              <a:rPr lang="en-IN" sz="2000" dirty="0">
+                <a:solidFill>
+                  <a:schemeClr val="bg1">
+                    <a:lumMod val="95000"/>
+                  </a:schemeClr>
+                </a:solidFill>
+              </a:rPr>
+              <a:t>_No</a:t>
+            </a:r>
+            <a:r>
+              <a:rPr lang="en-US" sz="2000" dirty="0">
+                <a:solidFill>
+                  <a:schemeClr val="bg1">
+                    <a:lumMod val="95000"/>
+                  </a:schemeClr>
+                </a:solidFill>
+              </a:rPr>
+              <a:t>: 14                      </a:t>
+            </a:r>
+            <a:r>
+              <a:rPr sz="2000" dirty="0">
+                <a:solidFill>
+                  <a:schemeClr val="bg1">
+                    <a:lumMod val="95000"/>
+                  </a:schemeClr>
+                </a:solidFill>
+              </a:rPr>
+              <a:t>	</a:t>
+            </a:r>
+            <a:endParaRPr lang="en-US" sz="2000" dirty="0">
+              <a:solidFill>
+                <a:schemeClr val="bg1">
+                  <a:lumMod val="95000"/>
+                </a:schemeClr>
+              </a:solidFill>
+              <a:ea typeface="Calibri"/>
+              <a:cs typeface="Calibri"/>
+            </a:endParaRPr>
+          </a:p>
+          <a:p>
+            <a:pPr>
+              <a:lnSpc>
+                <a:spcPct val="80000"/>
+              </a:lnSpc>
+              <a:spcBef>
+                <a:spcPts val="400"/>
+              </a:spcBef>
+              <a:defRPr sz="2000"/>
+            </a:pPr>
+            <a:endParaRPr lang="en-US" sz="2000" dirty="0">
+              <a:solidFill>
+                <a:schemeClr val="bg1">
+                  <a:lumMod val="95000"/>
+                </a:schemeClr>
+              </a:solidFill>
+              <a:latin typeface="Times New Roman" panose="02020603050405020304" pitchFamily="18" charset="0"/>
+              <a:cs typeface="Times New Roman" panose="02020603050405020304" pitchFamily="18" charset="0"/>
+            </a:endParaRPr>
+          </a:p>
+          <a:p>
+            <a:pPr>
+              <a:lnSpc>
+                <a:spcPct val="80000"/>
+              </a:lnSpc>
+              <a:spcBef>
+                <a:spcPts val="400"/>
+              </a:spcBef>
+              <a:defRPr sz="2000"/>
+            </a:pPr>
+            <a:endParaRPr sz="2000" dirty="0">
+              <a:solidFill>
+                <a:schemeClr val="bg1">
+                  <a:lumMod val="95000"/>
+                </a:schemeClr>
+              </a:solidFill>
+              <a:latin typeface="Times New Roman" panose="02020603050405020304" pitchFamily="18" charset="0"/>
+              <a:cs typeface="Times New Roman" panose="02020603050405020304" pitchFamily="18" charset="0"/>
+            </a:endParaRPr>
+          </a:p>
+          <a:p>
+            <a:pPr>
+              <a:lnSpc>
+                <a:spcPct val="80000"/>
+              </a:lnSpc>
+              <a:spcBef>
+                <a:spcPts val="400"/>
+              </a:spcBef>
+              <a:defRPr sz="2000"/>
+            </a:pPr>
+            <a:endParaRPr sz="2000" dirty="0">
+              <a:solidFill>
+                <a:schemeClr val="bg1">
+                  <a:lumMod val="95000"/>
+                </a:schemeClr>
+              </a:solidFill>
+              <a:latin typeface="Times New Roman" panose="02020603050405020304" pitchFamily="18" charset="0"/>
+              <a:cs typeface="Times New Roman" panose="02020603050405020304" pitchFamily="18" charset="0"/>
+            </a:endParaRPr>
+          </a:p>
+          <a:p>
+            <a:pPr>
+              <a:lnSpc>
+                <a:spcPct val="80000"/>
+              </a:lnSpc>
+              <a:spcBef>
+                <a:spcPts val="400"/>
+              </a:spcBef>
+              <a:defRPr sz="2000" b="1">
+                <a:latin typeface="+mn-lt"/>
+                <a:ea typeface="+mn-ea"/>
+                <a:cs typeface="+mn-cs"/>
+                <a:sym typeface="Arial"/>
+              </a:defRPr>
+            </a:pPr>
+            <a:endParaRPr lang="en-IN" sz="2000" dirty="0">
+              <a:solidFill>
+                <a:schemeClr val="bg1">
+                  <a:lumMod val="95000"/>
+                </a:schemeClr>
+              </a:solidFill>
+              <a:latin typeface="Times New Roman" panose="02020603050405020304" pitchFamily="18" charset="0"/>
+              <a:cs typeface="Times New Roman" panose="02020603050405020304" pitchFamily="18" charset="0"/>
+            </a:endParaRPr>
+          </a:p>
+          <a:p>
+            <a:pPr>
+              <a:lnSpc>
+                <a:spcPct val="80000"/>
+              </a:lnSpc>
+              <a:spcBef>
+                <a:spcPts val="400"/>
+              </a:spcBef>
+              <a:defRPr sz="2000" b="1">
+                <a:latin typeface="+mn-lt"/>
+                <a:ea typeface="+mn-ea"/>
+                <a:cs typeface="+mn-cs"/>
+                <a:sym typeface="Arial"/>
+              </a:defRPr>
+            </a:pPr>
+            <a:endParaRPr lang="en-IN" sz="2000" dirty="0">
+              <a:solidFill>
+                <a:schemeClr val="bg1">
+                  <a:lumMod val="95000"/>
+                </a:schemeClr>
+              </a:solidFill>
+              <a:latin typeface="Times New Roman" panose="02020603050405020304" pitchFamily="18" charset="0"/>
+              <a:cs typeface="Times New Roman" panose="02020603050405020304" pitchFamily="18" charset="0"/>
+            </a:endParaRPr>
+          </a:p>
+          <a:p>
+            <a:pPr>
+              <a:lnSpc>
+                <a:spcPct val="80000"/>
+              </a:lnSpc>
+              <a:spcBef>
+                <a:spcPts val="400"/>
+              </a:spcBef>
+              <a:defRPr sz="2000" b="1">
+                <a:latin typeface="+mn-lt"/>
+                <a:ea typeface="+mn-ea"/>
+                <a:cs typeface="+mn-cs"/>
+                <a:sym typeface="Arial"/>
+              </a:defRPr>
+            </a:pPr>
+            <a:endParaRPr lang="en-IN" sz="2000" dirty="0">
+              <a:solidFill>
+                <a:schemeClr val="bg1">
+                  <a:lumMod val="95000"/>
+                </a:schemeClr>
+              </a:solidFill>
+              <a:latin typeface="Times New Roman" panose="02020603050405020304" pitchFamily="18" charset="0"/>
+              <a:cs typeface="Times New Roman" panose="02020603050405020304" pitchFamily="18" charset="0"/>
+            </a:endParaRPr>
+          </a:p>
+          <a:p>
+            <a:pPr>
+              <a:lnSpc>
+                <a:spcPct val="80000"/>
+              </a:lnSpc>
+              <a:spcBef>
+                <a:spcPts val="400"/>
+              </a:spcBef>
+              <a:defRPr sz="2000" b="1">
+                <a:latin typeface="+mn-lt"/>
+                <a:ea typeface="+mn-ea"/>
+                <a:cs typeface="+mn-cs"/>
+                <a:sym typeface="Arial"/>
+              </a:defRPr>
+            </a:pPr>
+            <a:endParaRPr lang="en-IN" sz="2000" dirty="0">
+              <a:solidFill>
+                <a:schemeClr val="bg1">
+                  <a:lumMod val="95000"/>
+                </a:schemeClr>
+              </a:solidFill>
+              <a:latin typeface="Times New Roman" panose="02020603050405020304" pitchFamily="18" charset="0"/>
+              <a:cs typeface="Times New Roman" panose="02020603050405020304" pitchFamily="18" charset="0"/>
+            </a:endParaRPr>
           </a:p>
         </p:txBody>
       </p:sp>
       <p:graphicFrame>
         <p:nvGraphicFramePr>
-          <p:cNvPr id="5" name="Table 4">
+          <p:cNvPr id="16" name="Table 16">
             <a:extLst>
               <a:ext uri="{FF2B5EF4-FFF2-40B4-BE49-F238E27FC236}">
-                <a16:creationId xmlns:a16="http://schemas.microsoft.com/office/drawing/2014/main" id="{2BAA7EE0-C9C8-EBBC-183F-39AA66A5DEE3}"/>
+                <a16:creationId xmlns:a16="http://schemas.microsoft.com/office/drawing/2014/main" id="{A63BE85B-6374-76D7-5E38-FC60C7AC7E8A}"/>
               </a:ext>
             </a:extLst>
           </p:cNvPr>
@@ -3305,14 +3430,14 @@
           <p:nvPr>
             <p:extLst>
               <p:ext uri="{D42A27DB-BD31-4B8C-83A1-F6EECF244321}">
-                <p14:modId xmlns:p14="http://schemas.microsoft.com/office/powerpoint/2010/main" val="3470673375"/>
+                <p14:modId xmlns:p14="http://schemas.microsoft.com/office/powerpoint/2010/main" val="1944519078"/>
               </p:ext>
             </p:extLst>
           </p:nvPr>
         </p:nvGraphicFramePr>
         <p:xfrm>
-          <a:off x="2039620" y="3118440"/>
-          <a:ext cx="8127999" cy="1112520"/>
+          <a:off x="2025804" y="2787805"/>
+          <a:ext cx="8113789" cy="2651760"/>
         </p:xfrm>
         <a:graphic>
           <a:graphicData uri="http://schemas.openxmlformats.org/drawingml/2006/table">
@@ -3321,35 +3446,145 @@
                 <a:tableStyleId>{5940675A-B579-460E-94D1-54222C63F5DA}</a:tableStyleId>
               </a:tblPr>
               <a:tblGrid>
-                <a:gridCol w="964837">
+                <a:gridCol w="1638994">
                   <a:extLst>
                     <a:ext uri="{9D8B030D-6E8A-4147-A177-3AD203B41FA5}">
-                      <a16:colId xmlns:a16="http://schemas.microsoft.com/office/drawing/2014/main" val="2848098960"/>
+                      <a16:colId xmlns:a16="http://schemas.microsoft.com/office/drawing/2014/main" val="3821791271"/>
                     </a:ext>
                   </a:extLst>
                 </a:gridCol>
-                <a:gridCol w="4453829">
+                <a:gridCol w="3014548">
                   <a:extLst>
                     <a:ext uri="{9D8B030D-6E8A-4147-A177-3AD203B41FA5}">
-                      <a16:colId xmlns:a16="http://schemas.microsoft.com/office/drawing/2014/main" val="2209025043"/>
+                      <a16:colId xmlns:a16="http://schemas.microsoft.com/office/drawing/2014/main" val="3813364352"/>
                     </a:ext>
                   </a:extLst>
                 </a:gridCol>
-                <a:gridCol w="2709333">
+                <a:gridCol w="3460247">
                   <a:extLst>
                     <a:ext uri="{9D8B030D-6E8A-4147-A177-3AD203B41FA5}">
-                      <a16:colId xmlns:a16="http://schemas.microsoft.com/office/drawing/2014/main" val="1752322375"/>
+                      <a16:colId xmlns:a16="http://schemas.microsoft.com/office/drawing/2014/main" val="2182017130"/>
                     </a:ext>
                   </a:extLst>
                 </a:gridCol>
               </a:tblGrid>
-              <a:tr h="370840">
+              <a:tr h="318640">
                 <a:tc>
                   <a:txBody>
                     <a:bodyPr/>
                     <a:lstStyle/>
                     <a:p>
+                      <a:pPr algn="ctr"/>
                       <a:r>
+                        <a:rPr lang="en-IN" sz="1800" b="1" dirty="0">
+                          <a:solidFill>
+                            <a:schemeClr val="bg1">
+                              <a:lumMod val="95000"/>
+                            </a:schemeClr>
+                          </a:solidFill>
+                          <a:latin typeface="Times New Roman" panose="02020603050405020304" pitchFamily="18" charset="0"/>
+                          <a:cs typeface="Times New Roman" panose="02020603050405020304" pitchFamily="18" charset="0"/>
+                        </a:rPr>
+                        <a:t>Sl. No.</a:t>
+                      </a:r>
+                      <a:endParaRPr lang="en-US" sz="1800" b="1" dirty="0">
+                        <a:solidFill>
+                          <a:schemeClr val="bg1">
+                            <a:lumMod val="95000"/>
+                          </a:schemeClr>
+                        </a:solidFill>
+                        <a:latin typeface="Times New Roman" panose="02020603050405020304" pitchFamily="18" charset="0"/>
+                        <a:cs typeface="Times New Roman" panose="02020603050405020304" pitchFamily="18" charset="0"/>
+                      </a:endParaRPr>
+                    </a:p>
+                  </a:txBody>
+                  <a:tcPr/>
+                </a:tc>
+                <a:tc>
+                  <a:txBody>
+                    <a:bodyPr/>
+                    <a:lstStyle/>
+                    <a:p>
+                      <a:pPr algn="ctr"/>
+                      <a:r>
+                        <a:rPr lang="en-IN" sz="1800" b="1" dirty="0">
+                          <a:solidFill>
+                            <a:schemeClr val="bg1">
+                              <a:lumMod val="95000"/>
+                            </a:schemeClr>
+                          </a:solidFill>
+                          <a:latin typeface="Times New Roman" panose="02020603050405020304" pitchFamily="18" charset="0"/>
+                          <a:cs typeface="Times New Roman" panose="02020603050405020304" pitchFamily="18" charset="0"/>
+                        </a:rPr>
+                        <a:t>Reg. No.</a:t>
+                      </a:r>
+                      <a:endParaRPr lang="en-US" sz="1800" b="1" dirty="0">
+                        <a:solidFill>
+                          <a:schemeClr val="bg1">
+                            <a:lumMod val="95000"/>
+                          </a:schemeClr>
+                        </a:solidFill>
+                        <a:latin typeface="Times New Roman" panose="02020603050405020304" pitchFamily="18" charset="0"/>
+                        <a:cs typeface="Times New Roman" panose="02020603050405020304" pitchFamily="18" charset="0"/>
+                      </a:endParaRPr>
+                    </a:p>
+                  </a:txBody>
+                  <a:tcPr/>
+                </a:tc>
+                <a:tc>
+                  <a:txBody>
+                    <a:bodyPr/>
+                    <a:lstStyle/>
+                    <a:p>
+                      <a:pPr algn="ctr"/>
+                      <a:r>
+                        <a:rPr lang="en-IN" sz="1800" b="1" dirty="0">
+                          <a:solidFill>
+                            <a:schemeClr val="bg1">
+                              <a:lumMod val="95000"/>
+                            </a:schemeClr>
+                          </a:solidFill>
+                          <a:latin typeface="Times New Roman" panose="02020603050405020304" pitchFamily="18" charset="0"/>
+                          <a:cs typeface="Times New Roman" panose="02020603050405020304" pitchFamily="18" charset="0"/>
+                        </a:rPr>
+                        <a:t>Name of the student</a:t>
+                      </a:r>
+                      <a:endParaRPr lang="en-US" sz="1800" b="1" dirty="0">
+                        <a:solidFill>
+                          <a:schemeClr val="bg1">
+                            <a:lumMod val="95000"/>
+                          </a:schemeClr>
+                        </a:solidFill>
+                        <a:latin typeface="Times New Roman" panose="02020603050405020304" pitchFamily="18" charset="0"/>
+                        <a:cs typeface="Times New Roman" panose="02020603050405020304" pitchFamily="18" charset="0"/>
+                      </a:endParaRPr>
+                    </a:p>
+                  </a:txBody>
+                  <a:tcPr/>
+                </a:tc>
+                <a:extLst>
+                  <a:ext uri="{0D108BD9-81ED-4DB2-BD59-A6C34878D82A}">
+                    <a16:rowId xmlns:a16="http://schemas.microsoft.com/office/drawing/2014/main" val="3680690979"/>
+                  </a:ext>
+                </a:extLst>
+              </a:tr>
+              <a:tr h="557621">
+                <a:tc>
+                  <a:txBody>
+                    <a:bodyPr/>
+                    <a:lstStyle/>
+                    <a:p>
+                      <a:pPr algn="ctr"/>
+                      <a:r>
+                        <a:rPr lang="en-US" sz="1800" b="1" dirty="0">
+                          <a:solidFill>
+                            <a:schemeClr val="bg1">
+                              <a:lumMod val="95000"/>
+                            </a:schemeClr>
+                          </a:solidFill>
+                          <a:latin typeface="Times New Roman" panose="02020603050405020304" pitchFamily="18" charset="0"/>
+                          <a:cs typeface="Times New Roman" panose="02020603050405020304" pitchFamily="18" charset="0"/>
+                        </a:rPr>
                         <a:t>1</a:t>
                       </a:r>
                     </a:p>
@@ -3361,9 +3596,69 @@
                     <a:bodyPr/>
                     <a:lstStyle/>
                     <a:p>
+                      <a:pPr lvl="0" algn="ctr">
+                        <a:lnSpc>
+                          <a:spcPct val="100000"/>
+                        </a:lnSpc>
+                        <a:spcBef>
+                          <a:spcPts val="0"/>
+                        </a:spcBef>
+                        <a:spcAft>
+                          <a:spcPts val="0"/>
+                        </a:spcAft>
+                        <a:buNone/>
+                      </a:pPr>
                       <a:r>
-                        <a:t>K. Harshith</a:t>
+                        <a:rPr lang="en-US" sz="1800" b="1" i="0" u="none" strike="noStrike" noProof="0" dirty="0">
+                          <a:solidFill>
+                            <a:schemeClr val="bg1">
+                              <a:lumMod val="95000"/>
+                            </a:schemeClr>
+                          </a:solidFill>
+                          <a:latin typeface="Times New Roman"/>
+                          <a:ea typeface="Times New Roman"/>
+                          <a:cs typeface="Times New Roman"/>
+                        </a:rPr>
+                        <a:t>BL.SC.U4AIE24125</a:t>
                       </a:r>
+                      <a:endParaRPr lang="en-US" sz="1800" b="0" i="0" u="none" strike="noStrike" noProof="0" dirty="0">
+                        <a:solidFill>
+                          <a:srgbClr val="000000"/>
+                        </a:solidFill>
+                        <a:latin typeface="Times New Roman"/>
+                        <a:ea typeface="Times New Roman"/>
+                        <a:cs typeface="Times New Roman"/>
+                      </a:endParaRPr>
+                    </a:p>
+                    <a:p>
+                      <a:pPr marL="0" marR="0" lvl="0" indent="0" algn="ctr" defTabSz="685800">
+                        <a:lnSpc>
+                          <a:spcPct val="100000"/>
+                        </a:lnSpc>
+                        <a:spcBef>
+                          <a:spcPts val="0"/>
+                        </a:spcBef>
+                        <a:spcAft>
+                          <a:spcPts val="0"/>
+                        </a:spcAft>
+                        <a:buClrTx/>
+                        <a:buSzTx/>
+                        <a:buFontTx/>
+                        <a:buNone/>
+                        <a:tabLst/>
+                        <a:defRPr/>
+                      </a:pPr>
+                      <a:endParaRPr lang="en-US" sz="1800" b="1" dirty="0">
+                        <a:solidFill>
+                          <a:schemeClr val="bg1">
+                            <a:lumMod val="95000"/>
+                          </a:schemeClr>
+                        </a:solidFill>
+                        <a:latin typeface="Times New Roman"/>
+                        <a:ea typeface="Times New Roman"/>
+                        <a:cs typeface="Times New Roman"/>
+                        <a:sym typeface="Times New Roman"/>
+                      </a:endParaRPr>
                     </a:p>
                   </a:txBody>
                   <a:tcPr/>
@@ -3373,26 +3668,74 @@
                     <a:bodyPr/>
                     <a:lstStyle/>
                     <a:p>
+                      <a:pPr marL="0" marR="0" lvl="0" indent="0" algn="ctr" defTabSz="685800" rtl="0" eaLnBrk="1" fontAlgn="auto" latinLnBrk="0" hangingPunct="1">
+                        <a:lnSpc>
+                          <a:spcPct val="100000"/>
+                        </a:lnSpc>
+                        <a:spcBef>
+                          <a:spcPts val="0"/>
+                        </a:spcBef>
+                        <a:spcAft>
+                          <a:spcPts val="0"/>
+                        </a:spcAft>
+                        <a:buClrTx/>
+                        <a:buSzTx/>
+                        <a:buFontTx/>
+                        <a:buNone/>
+                        <a:tabLst/>
+                        <a:defRPr/>
+                      </a:pPr>
                       <a:r>
-                        <a:t>23BD1A0583</a:t>
+                        <a:rPr lang="en-US" sz="1800" b="1" dirty="0" err="1">
+                          <a:solidFill>
+                            <a:schemeClr val="bg1">
+                              <a:lumMod val="95000"/>
+                            </a:schemeClr>
+                          </a:solidFill>
+                          <a:latin typeface="Times New Roman"/>
+                          <a:ea typeface="Times New Roman"/>
+                          <a:cs typeface="Times New Roman"/>
+                        </a:rPr>
+                        <a:t>K.Harshith</a:t>
                       </a:r>
+                      <a:endParaRPr lang="en-US" sz="1800" b="1" dirty="0" err="1">
+                        <a:solidFill>
+                          <a:schemeClr val="bg1">
+                            <a:lumMod val="95000"/>
+                          </a:schemeClr>
+                        </a:solidFill>
+                        <a:latin typeface="Times New Roman"/>
+                        <a:ea typeface="Times New Roman"/>
+                        <a:cs typeface="Times New Roman"/>
+                        <a:sym typeface="Times New Roman"/>
+                      </a:endParaRPr>
                     </a:p>
                   </a:txBody>
                   <a:tcPr/>
                 </a:tc>
                 <a:extLst>
                   <a:ext uri="{0D108BD9-81ED-4DB2-BD59-A6C34878D82A}">
-                    <a16:rowId xmlns:a16="http://schemas.microsoft.com/office/drawing/2014/main" val="1597931389"/>
+                    <a16:rowId xmlns:a16="http://schemas.microsoft.com/office/drawing/2014/main" val="735749463"/>
                   </a:ext>
                 </a:extLst>
               </a:tr>
-              <a:tr h="370840">
+              <a:tr h="557621">
                 <a:tc>
                   <a:txBody>
                     <a:bodyPr/>
                     <a:lstStyle/>
                     <a:p>
+                      <a:pPr algn="ctr"/>
                       <a:r>
+                        <a:rPr lang="en-US" sz="1800" b="1" dirty="0">
+                          <a:solidFill>
+                            <a:schemeClr val="bg1">
+                              <a:lumMod val="95000"/>
+                            </a:schemeClr>
+                          </a:solidFill>
+                          <a:latin typeface="Times New Roman" panose="02020603050405020304" pitchFamily="18" charset="0"/>
+                          <a:cs typeface="Times New Roman" panose="02020603050405020304" pitchFamily="18" charset="0"/>
+                        </a:rPr>
                         <a:t>2</a:t>
                       </a:r>
                     </a:p>
@@ -3404,9 +3747,69 @@
                     <a:bodyPr/>
                     <a:lstStyle/>
                     <a:p>
+                      <a:pPr lvl="0" algn="ctr">
+                        <a:lnSpc>
+                          <a:spcPct val="100000"/>
+                        </a:lnSpc>
+                        <a:spcBef>
+                          <a:spcPts val="0"/>
+                        </a:spcBef>
+                        <a:spcAft>
+                          <a:spcPts val="0"/>
+                        </a:spcAft>
+                        <a:buNone/>
+                      </a:pPr>
                       <a:r>
-                        <a:t>P. Manideep</a:t>
+                        <a:rPr lang="en-US" sz="1800" b="1" i="0" u="none" strike="noStrike" noProof="0" dirty="0">
+                          <a:solidFill>
+                            <a:schemeClr val="bg1">
+                              <a:lumMod val="95000"/>
+                            </a:schemeClr>
+                          </a:solidFill>
+                          <a:latin typeface="Times New Roman"/>
+                          <a:ea typeface="Times New Roman"/>
+                          <a:cs typeface="Times New Roman"/>
+                        </a:rPr>
+                        <a:t>BL.SC.U4AIE24162</a:t>
                       </a:r>
+                      <a:endParaRPr lang="en-US" sz="1800" b="0" i="0" u="none" strike="noStrike" noProof="0" dirty="0">
+                        <a:solidFill>
+                          <a:srgbClr val="000000"/>
+                        </a:solidFill>
+                        <a:latin typeface="Times New Roman"/>
+                        <a:ea typeface="Times New Roman"/>
+                        <a:cs typeface="Times New Roman"/>
+                      </a:endParaRPr>
+                    </a:p>
+                    <a:p>
+                      <a:pPr marL="0" marR="0" lvl="0" indent="0" algn="ctr" defTabSz="685800">
+                        <a:lnSpc>
+                          <a:spcPct val="100000"/>
+                        </a:lnSpc>
+                        <a:spcBef>
+                          <a:spcPts val="0"/>
+                        </a:spcBef>
+                        <a:spcAft>
+                          <a:spcPts val="0"/>
+                        </a:spcAft>
+                        <a:buClrTx/>
+                        <a:buSzTx/>
+                        <a:buFontTx/>
+                        <a:buNone/>
+                        <a:tabLst/>
+                        <a:defRPr/>
+                      </a:pPr>
+                      <a:endParaRPr lang="en-US" sz="1800" b="1" dirty="0">
+                        <a:solidFill>
+                          <a:schemeClr val="bg1">
+                            <a:lumMod val="95000"/>
+                          </a:schemeClr>
+                        </a:solidFill>
+                        <a:latin typeface="Times New Roman"/>
+                        <a:ea typeface="Times New Roman"/>
+                        <a:cs typeface="Times New Roman"/>
+                        <a:sym typeface="Times New Roman"/>
+                      </a:endParaRPr>
                     </a:p>
                   </a:txBody>
                   <a:tcPr/>
@@ -3416,26 +3819,76 @@
                     <a:bodyPr/>
                     <a:lstStyle/>
                     <a:p>
+                      <a:pPr marL="0" marR="0" lvl="0" indent="0" algn="ctr" defTabSz="685800" rtl="0" eaLnBrk="1" fontAlgn="auto" latinLnBrk="0" hangingPunct="1">
+                        <a:lnSpc>
+                          <a:spcPct val="100000"/>
+                        </a:lnSpc>
+                        <a:spcBef>
+                          <a:spcPts val="0"/>
+                        </a:spcBef>
+                        <a:spcAft>
+                          <a:spcPts val="0"/>
+                        </a:spcAft>
+                        <a:buClrTx/>
+                        <a:buSzTx/>
+                        <a:buFontTx/>
+                        <a:buNone/>
+                        <a:tabLst/>
+                        <a:defRPr/>
+                      </a:pPr>
                       <a:r>
-                        <a:t>23BD1A05AQ</a:t>
+                        <a:rPr lang="en-US" sz="1800" b="1" dirty="0" err="1">
+                          <a:solidFill>
+                            <a:schemeClr val="bg1">
+                              <a:lumMod val="95000"/>
+                            </a:schemeClr>
+                          </a:solidFill>
+                          <a:latin typeface="Times New Roman"/>
+                          <a:ea typeface="Times New Roman"/>
+                          <a:cs typeface="Times New Roman"/>
+                        </a:rPr>
+                        <a:t>P.Manideep</a:t>
                       </a:r>
+                      <a:endParaRPr lang="en-US" sz="1800" b="1" dirty="0" err="1">
+                        <a:solidFill>
+                          <a:schemeClr val="bg1">
+                            <a:lumMod val="95000"/>
+                          </a:schemeClr>
+                        </a:solidFill>
+                        <a:latin typeface="Times New Roman" panose="02020603050405020304" pitchFamily="18" charset="0"/>
+                        <a:ea typeface="Times New Roman"/>
+                        <a:cs typeface="Times New Roman" panose="02020603050405020304" pitchFamily="18" charset="0"/>
+                        <a:sym typeface="Times New Roman"/>
+                      </a:endParaRPr>
                     </a:p>
                   </a:txBody>
                   <a:tcPr/>
                 </a:tc>
                 <a:extLst>
                   <a:ext uri="{0D108BD9-81ED-4DB2-BD59-A6C34878D82A}">
-                    <a16:rowId xmlns:a16="http://schemas.microsoft.com/office/drawing/2014/main" val="3987390952"/>
+                    <a16:rowId xmlns:a16="http://schemas.microsoft.com/office/drawing/2014/main" val="2239897123"/>
                   </a:ext>
                 </a:extLst>
               </a:tr>
-              <a:tr h="370840">
+              <a:tr h="557621">
                 <a:tc>
                   <a:txBody>
                     <a:bodyPr/>
                     <a:lstStyle/>
                     <a:p>
+                      <a:pPr lvl="0" algn="ctr">
+                        <a:buNone/>
+                      </a:pPr>
                       <a:r>
+                        <a:rPr lang="en-US" sz="1800" b="1" dirty="0">
+                          <a:solidFill>
+                            <a:schemeClr val="bg1">
+                              <a:lumMod val="95000"/>
+                            </a:schemeClr>
+                          </a:solidFill>
+                          <a:latin typeface="Times New Roman"/>
+                          <a:cs typeface="Times New Roman"/>
+                        </a:rPr>
                         <a:t>3</a:t>
                       </a:r>
                     </a:p>
@@ -3447,9 +3900,66 @@
                     <a:bodyPr/>
                     <a:lstStyle/>
                     <a:p>
+                      <a:pPr lvl="0" algn="ctr">
+                        <a:lnSpc>
+                          <a:spcPct val="100000"/>
+                        </a:lnSpc>
+                        <a:spcBef>
+                          <a:spcPts val="0"/>
+                        </a:spcBef>
+                        <a:spcAft>
+                          <a:spcPts val="0"/>
+                        </a:spcAft>
+                        <a:buNone/>
+                      </a:pPr>
                       <a:r>
-                        <a:t>K. Rishvik</a:t>
+                        <a:rPr lang="en-US" sz="1800" b="1" i="0" u="none" strike="noStrike" noProof="0" dirty="0">
+                          <a:solidFill>
+                            <a:schemeClr val="bg1">
+                              <a:lumMod val="95000"/>
+                            </a:schemeClr>
+                          </a:solidFill>
+                          <a:latin typeface="Times New Roman"/>
+                          <a:ea typeface="Times New Roman"/>
+                          <a:cs typeface="Times New Roman"/>
+                        </a:rPr>
+                        <a:t>BL.SC.U4AIE24126</a:t>
                       </a:r>
+                      <a:endParaRPr lang="en-US" sz="1800" b="0" i="0" u="none" strike="noStrike" noProof="0" dirty="0">
+                        <a:solidFill>
+                          <a:srgbClr val="000000"/>
+                        </a:solidFill>
+                        <a:latin typeface="Times New Roman"/>
+                        <a:ea typeface="Times New Roman"/>
+                        <a:cs typeface="Times New Roman"/>
+                      </a:endParaRPr>
+                    </a:p>
+                    <a:p>
+                      <a:pPr marL="0" lvl="0" indent="0" algn="ctr" defTabSz="685800">
+                        <a:lnSpc>
+                          <a:spcPct val="100000"/>
+                        </a:lnSpc>
+                        <a:spcBef>
+                          <a:spcPts val="0"/>
+                        </a:spcBef>
+                        <a:spcAft>
+                          <a:spcPts val="0"/>
+                        </a:spcAft>
+                        <a:buNone/>
+                        <a:tabLst/>
+                        <a:defRPr/>
+                      </a:pPr>
+                      <a:endParaRPr lang="en-US" sz="1800" b="1" dirty="0">
+                        <a:solidFill>
+                          <a:schemeClr val="bg1">
+                            <a:lumMod val="95000"/>
+                          </a:schemeClr>
+                        </a:solidFill>
+                        <a:latin typeface="Times New Roman"/>
+                        <a:ea typeface="Times New Roman"/>
+                        <a:cs typeface="Times New Roman"/>
+                        <a:sym typeface="Times New Roman"/>
+                      </a:endParaRPr>
                     </a:p>
                   </a:txBody>
                   <a:tcPr/>
@@ -3459,16 +3969,147 @@
                     <a:bodyPr/>
                     <a:lstStyle/>
                     <a:p>
+                      <a:pPr marL="0" lvl="0" indent="0" algn="ctr" defTabSz="685800">
+                        <a:lnSpc>
+                          <a:spcPct val="100000"/>
+                        </a:lnSpc>
+                        <a:spcBef>
+                          <a:spcPts val="0"/>
+                        </a:spcBef>
+                        <a:spcAft>
+                          <a:spcPts val="0"/>
+                        </a:spcAft>
+                        <a:buNone/>
+                        <a:tabLst/>
+                        <a:defRPr/>
+                      </a:pPr>
                       <a:r>
-                        <a:t>23BD1A05AM</a:t>
+                        <a:rPr lang="en-US" sz="1800" b="1" dirty="0" err="1">
+                          <a:solidFill>
+                            <a:schemeClr val="bg1">
+                              <a:lumMod val="95000"/>
+                            </a:schemeClr>
+                          </a:solidFill>
+                          <a:latin typeface="Times New Roman"/>
+                          <a:ea typeface="Times New Roman"/>
+                          <a:cs typeface="Times New Roman"/>
+                        </a:rPr>
+                        <a:t>K.Rishvik</a:t>
                       </a:r>
+                      <a:endParaRPr lang="en-US" sz="1800" b="1" dirty="0" err="1">
+                        <a:solidFill>
+                          <a:schemeClr val="bg1">
+                            <a:lumMod val="95000"/>
+                          </a:schemeClr>
+                        </a:solidFill>
+                        <a:latin typeface="Times New Roman"/>
+                        <a:ea typeface="Times New Roman"/>
+                        <a:cs typeface="Times New Roman"/>
+                        <a:sym typeface="Times New Roman"/>
+                      </a:endParaRPr>
                     </a:p>
                   </a:txBody>
                   <a:tcPr/>
                 </a:tc>
                 <a:extLst>
                   <a:ext uri="{0D108BD9-81ED-4DB2-BD59-A6C34878D82A}">
-                    <a16:rowId xmlns:a16="http://schemas.microsoft.com/office/drawing/2014/main" val="2808924925"/>
+                    <a16:rowId xmlns:a16="http://schemas.microsoft.com/office/drawing/2014/main" val="3854110398"/>
+                  </a:ext>
+                </a:extLst>
+              </a:tr>
+              <a:tr h="318640">
+                <a:tc>
+                  <a:txBody>
+                    <a:bodyPr/>
+                    <a:lstStyle/>
+                    <a:p>
+                      <a:pPr lvl="0" algn="ctr">
+                        <a:buNone/>
+                      </a:pPr>
+                      <a:endParaRPr lang="en-US" sz="1800" b="1" dirty="0">
+                        <a:solidFill>
+                          <a:schemeClr val="bg1">
+                            <a:lumMod val="95000"/>
+                          </a:schemeClr>
+                        </a:solidFill>
+                        <a:latin typeface="Times New Roman"/>
+                        <a:cs typeface="Times New Roman"/>
+                      </a:endParaRPr>
+                    </a:p>
+                  </a:txBody>
+                  <a:tcPr/>
+                </a:tc>
+                <a:tc>
+                  <a:txBody>
+                    <a:bodyPr/>
+                    <a:lstStyle/>
+                    <a:p>
+                      <a:pPr marL="0" lvl="0" indent="0" algn="ctr" defTabSz="685800">
+                        <a:lnSpc>
+                          <a:spcPct val="100000"/>
+                        </a:lnSpc>
+                        <a:spcBef>
+                          <a:spcPts val="0"/>
+                        </a:spcBef>
+                        <a:spcAft>
+                          <a:spcPts val="0"/>
+                        </a:spcAft>
+                        <a:buNone/>
+                        <a:tabLst/>
+                        <a:defRPr/>
+                      </a:pPr>
+                      <a:endParaRPr lang="en-US" sz="1800" b="1" dirty="0">
+                        <a:solidFill>
+                          <a:schemeClr val="bg1">
+                            <a:lumMod val="95000"/>
+                          </a:schemeClr>
+                        </a:solidFill>
+                        <a:latin typeface="Times New Roman"/>
+                        <a:ea typeface="Times New Roman"/>
+                        <a:cs typeface="Times New Roman"/>
+                        <a:sym typeface="Times New Roman"/>
+                      </a:endParaRPr>
+                    </a:p>
+                  </a:txBody>
+                  <a:tcPr/>
+                </a:tc>
+                <a:tc>
+                  <a:txBody>
+                    <a:bodyPr/>
+                    <a:lstStyle/>
+                    <a:p>
+                      <a:pPr marL="0" lvl="0" indent="0" algn="ctr" defTabSz="685800">
+                        <a:lnSpc>
+                          <a:spcPct val="100000"/>
+                        </a:lnSpc>
+                        <a:spcBef>
+                          <a:spcPts val="0"/>
+                        </a:spcBef>
+                        <a:spcAft>
+                          <a:spcPts val="0"/>
+                        </a:spcAft>
+                        <a:buNone/>
+                        <a:tabLst/>
+                        <a:defRPr/>
+                      </a:pPr>
+                      <a:endParaRPr lang="en-US" sz="1800" b="1" dirty="0">
+                        <a:solidFill>
+                          <a:schemeClr val="bg1">
+                            <a:lumMod val="95000"/>
+                          </a:schemeClr>
+                        </a:solidFill>
+                        <a:latin typeface="Times New Roman"/>
+                        <a:ea typeface="Times New Roman"/>
+                        <a:cs typeface="Times New Roman"/>
+                        <a:sym typeface="Times New Roman"/>
+                      </a:endParaRPr>
+                    </a:p>
+                  </a:txBody>
+                  <a:tcPr/>
+                </a:tc>
+                <a:extLst>
+                  <a:ext uri="{0D108BD9-81ED-4DB2-BD59-A6C34878D82A}">
+                    <a16:rowId xmlns:a16="http://schemas.microsoft.com/office/drawing/2014/main" val="1495774805"/>
                   </a:ext>
                 </a:extLst>
               </a:tr>
@@ -3476,6 +4117,48 @@
           </a:graphicData>
         </a:graphic>
       </p:graphicFrame>
+      <p:sp>
+        <p:nvSpPr>
+          <p:cNvPr id="5" name="TextBox 4">
+            <a:extLst>
+              <a:ext uri="{FF2B5EF4-FFF2-40B4-BE49-F238E27FC236}">
+                <a16:creationId xmlns:a16="http://schemas.microsoft.com/office/drawing/2014/main" id="{0B5A57B1-73F3-2FD3-98C7-BE028EBD9C30}"/>
+              </a:ext>
+            </a:extLst>
+          </p:cNvPr>
+          <p:cNvSpPr txBox="1"/>
+          <p:nvPr/>
+        </p:nvSpPr>
+        <p:spPr>
+          <a:xfrm>
+            <a:off x="7238134" y="2315275"/>
+            <a:ext cx="2125961" cy="369332"/>
+          </a:xfrm>
+          <a:prstGeom prst="rect">
+            <a:avLst/>
+          </a:prstGeom>
+          <a:noFill/>
+        </p:spPr>
+        <p:txBody>
+          <a:bodyPr rot="0" spcFirstLastPara="0" vertOverflow="overflow" horzOverflow="overflow" vert="horz" wrap="square" lIns="91440" tIns="45720" rIns="91440" bIns="45720" numCol="1" spcCol="0" rtlCol="0" fromWordArt="0" anchor="t" anchorCtr="0" forceAA="0" compatLnSpc="1">
+            <a:prstTxWarp prst="textNoShape">
+              <a:avLst/>
+            </a:prstTxWarp>
+            <a:spAutoFit/>
+          </a:bodyPr>
+          <a:lstStyle/>
+          <a:p>
+            <a:r>
+              <a:rPr lang="en-US" sz="1800" dirty="0">
+                <a:solidFill>
+                  <a:schemeClr val="bg1"/>
+                </a:solidFill>
+              </a:rPr>
+              <a:t>Faculty : KV Divya</a:t>
+            </a:r>
+          </a:p>
+        </p:txBody>
+      </p:sp>
     </p:spTree>
     <p:extLst>
       <p:ext uri="{BB962C8B-B14F-4D97-AF65-F5344CB8AC3E}">
@@ -8379,13 +9062,13 @@
         </p:nvSpPr>
         <p:spPr>
           <a:xfrm>
-            <a:off x="1121979" y="2398881"/>
-            <a:ext cx="10515600" cy="1325563"/>
+            <a:off x="5926296" y="6218174"/>
+            <a:ext cx="4698381" cy="489221"/>
           </a:xfrm>
         </p:spPr>
         <p:txBody>
           <a:bodyPr>
-            <a:normAutofit/>
+            <a:normAutofit fontScale="90000"/>
           </a:bodyPr>
           <a:lstStyle/>
           <a:p>
@@ -8403,8 +9086,8 @@
         </p:nvSpPr>
         <p:spPr>
           <a:xfrm>
-            <a:off x="1371600" y="1371600"/>
-            <a:ext cx="8229600" cy="3931920"/>
+            <a:off x="1250796" y="795454"/>
+            <a:ext cx="8350404" cy="4508066"/>
           </a:xfrm>
           <a:prstGeom prst="roundRect">
             <a:avLst/>
@@ -8433,7 +9116,7 @@
           </a:fontRef>
         </p:style>
         <p:txBody>
-          <a:bodyPr rtlCol="0" anchor="ctr" wrap="square" lIns="274320" tIns="182880"/>
+          <a:bodyPr wrap="square" lIns="274320" tIns="182880" rtlCol="0" anchor="ctr"/>
           <a:lstStyle/>
           <a:p>
             <a:pPr algn="ctr">
@@ -8495,6 +9178,7 @@
                 <a:latin typeface="Calibri"/>
               </a:defRPr>
             </a:pPr>
+            <a:endParaRPr/>
           </a:p>
           <a:p>
             <a:pPr>
@@ -8572,6 +9256,7 @@
                 <a:latin typeface="Calibri"/>
               </a:defRPr>
             </a:pPr>
+            <a:endParaRPr/>
           </a:p>
           <a:p>
             <a:pPr>
@@ -8617,6 +9302,7 @@
                 <a:latin typeface="Calibri"/>
               </a:defRPr>
             </a:pPr>
+            <a:endParaRPr/>
           </a:p>
           <a:p>
             <a:pPr>
@@ -18554,7 +19240,7 @@
         </p:nvGraphicFramePr>
         <p:xfrm>
           <a:off x="411480" y="2816352"/>
-          <a:ext cx="2743200" cy="2926080"/>
+          <a:ext cx="2743200" cy="3008376"/>
         </p:xfrm>
         <a:graphic>
           <a:graphicData uri="http://schemas.openxmlformats.org/drawingml/2006/table">
@@ -18856,7 +19542,9 @@
                   <a:txBody>
                     <a:bodyPr/>
                     <a:lstStyle/>
-                    <a:p/>
+                    <a:p>
+                      <a:endParaRPr/>
+                    </a:p>
                   </a:txBody>
                   <a:tcPr marL="54864" marR="54864" marT="18288" marB="18288" anchor="ctr">
                     <a:solidFill>
@@ -18868,7 +19556,9 @@
                   <a:txBody>
                     <a:bodyPr/>
                     <a:lstStyle/>
-                    <a:p/>
+                    <a:p>
+                      <a:endParaRPr/>
+                    </a:p>
                   </a:txBody>
                   <a:tcPr marL="54864" marR="54864" marT="18288" marB="18288" anchor="ctr">
                     <a:solidFill>
@@ -18896,7 +19586,7 @@
         </p:nvGraphicFramePr>
         <p:xfrm>
           <a:off x="3282696" y="2816352"/>
-          <a:ext cx="2743200" cy="3291840"/>
+          <a:ext cx="2743200" cy="3374136"/>
         </p:xfrm>
         <a:graphic>
           <a:graphicData uri="http://schemas.openxmlformats.org/drawingml/2006/table">
@@ -19289,7 +19979,7 @@
         </p:nvGraphicFramePr>
         <p:xfrm>
           <a:off x="6153912" y="2816352"/>
-          <a:ext cx="2743200" cy="2194560"/>
+          <a:ext cx="2743200" cy="2359152"/>
         </p:xfrm>
         <a:graphic>
           <a:graphicData uri="http://schemas.openxmlformats.org/drawingml/2006/table">
@@ -19561,7 +20251,7 @@
         </p:nvGraphicFramePr>
         <p:xfrm>
           <a:off x="9025128" y="2816352"/>
-          <a:ext cx="2743200" cy="2926080"/>
+          <a:ext cx="2743200" cy="3090672"/>
         </p:xfrm>
         <a:graphic>
           <a:graphicData uri="http://schemas.openxmlformats.org/drawingml/2006/table">
@@ -23952,7 +24642,9 @@
                   <a:txBody>
                     <a:bodyPr/>
                     <a:lstStyle/>
-                    <a:p/>
+                    <a:p>
+                      <a:endParaRPr/>
+                    </a:p>
                   </a:txBody>
                   <a:tcPr marL="54864" marR="54864" marT="18288" marB="18288" anchor="ctr">
                     <a:solidFill>
@@ -24026,7 +24718,9 @@
                   <a:txBody>
                     <a:bodyPr/>
                     <a:lstStyle/>
-                    <a:p/>
+                    <a:p>
+                      <a:endParaRPr/>
+                    </a:p>
                   </a:txBody>
                   <a:tcPr marL="54864" marR="54864" marT="18288" marB="18288" anchor="ctr">
                     <a:solidFill>
@@ -24138,7 +24832,9 @@
                   <a:txBody>
                     <a:bodyPr/>
                     <a:lstStyle/>
-                    <a:p/>
+                    <a:p>
+                      <a:endParaRPr/>
+                    </a:p>
                   </a:txBody>
                   <a:tcPr marL="54864" marR="54864" marT="18288" marB="18288" anchor="ctr">
                     <a:solidFill>
@@ -24212,7 +24908,9 @@
                   <a:txBody>
                     <a:bodyPr/>
                     <a:lstStyle/>
-                    <a:p/>
+                    <a:p>
+                      <a:endParaRPr/>
+                    </a:p>
                   </a:txBody>
                   <a:tcPr marL="54864" marR="54864" marT="18288" marB="18288" anchor="ctr">
                     <a:solidFill>

</xml_diff>